<commit_message>
Use part durations in the agenda and add a Q&A follow-up slide
The agenda cards now show each part's length (20/35/25/20 min), matching
the section kickers, instead of elapsed clock times. The lab guide shows
hands-on time (5/10/25/15/15 min), matching the hands-on pills; the
elapsed timeline stays in the slide 2 speaker notes.

Also adds a note on the agenda slide about bringing your own problem to
RCC afterwards, and a closing slide with the follow-up email format.
</commit_message>
<xml_diff>
--- a/slides/E4S_Workshop_RCC_2026-10-27.pptx
+++ b/slides/E4S_Workshop_RCC_2026-10-27.pptx
@@ -37,9 +37,10 @@
     <p:sldId id="285" r:id="rId31"/>
     <p:sldId id="286" r:id="rId32"/>
     <p:sldId id="287" r:id="rId33"/>
+    <p:sldId id="288" r:id="rId34"/>
   </p:sldIdLst>
   <p:notesMasterIdLst>
-    <p:notesMasterId r:id="rId34"/>
+    <p:notesMasterId r:id="rId35"/>
   </p:notesMasterIdLst>
   <p:sldSz cx="12192000" cy="6858000"/>
   <p:notesSz cx="6858000" cy="12192000"/>
@@ -138,7 +139,7 @@
   <p:extLst>
     <p:ext uri="{521415D9-36F7-43E2-AB2F-B90AF26B5E84}">
       <p14:sectionLst xmlns:p14="http://schemas.microsoft.com/office/powerpoint/2010/main">
-        <p14:section name="Opening" id="{0b264608-2b42-8a1b-a846-53bcf656dcb0}">
+        <p14:section name="Opening" id="{1e013ab6-07ef-e409-9beb-1b785ddd4d8b}">
           <p14:sldIdLst>
             <p14:sldId id="256"/>
             <p14:sldId id="257"/>
@@ -146,7 +147,7 @@
             <p14:sldId id="259"/>
           </p14:sldIdLst>
         </p14:section>
-        <p14:section name="Part 1: Containers on HPC" id="{1d17e43a-51fe-5236-90b8-0fea4e29e4a6}">
+        <p14:section name="Part 1: Containers on HPC" id="{ec590041-eabb-e259-6aea-5c9ae9c45f25}">
           <p14:sldIdLst>
             <p14:sldId id="260"/>
             <p14:sldId id="261"/>
@@ -156,7 +157,7 @@
             <p14:sldId id="265"/>
           </p14:sldIdLst>
         </p14:section>
-        <p14:section name="Part 2: Pull, inspect, run" id="{e435b60a-09fa-8513-7789-33c0740abe56}">
+        <p14:section name="Part 2: Pull, inspect, run" id="{63c40bf0-ae65-c6d2-38fb-dd6d3ac525d4}">
           <p14:sldIdLst>
             <p14:sldId id="266"/>
             <p14:sldId id="267"/>
@@ -168,7 +169,7 @@
             <p14:sldId id="273"/>
           </p14:sldIdLst>
         </p14:section>
-        <p14:section name="Part 3: e4s-cl and e4s-alc" id="{6b3c2a4c-1a76-b42b-276b-f562cd27094c}">
+        <p14:section name="Part 3: e4s-cl and e4s-alc" id="{b18ef15b-43af-6bea-3426-ac6abc5d98e0}">
           <p14:sldIdLst>
             <p14:sldId id="274"/>
             <p14:sldId id="275"/>
@@ -183,11 +184,12 @@
             <p14:sldId id="284"/>
           </p14:sldIdLst>
         </p14:section>
-        <p14:section name="Wrap-up" id="{d29bec0f-2164-ec3e-ddb9-42cdbd4bcd14}">
+        <p14:section name="Wrap-up" id="{4c54215b-8f6b-e310-9293-e458dfbdf2a0}">
           <p14:sldIdLst>
             <p14:sldId id="285"/>
             <p14:sldId id="286"/>
             <p14:sldId id="287"/>
+            <p14:sldId id="288"/>
           </p14:sldIdLst>
         </p14:section>
       </p14:sectionLst>
@@ -2146,7 +2148,7 @@
           <a:p>
             <a:r>
               <a:rPr lang="en-US" dirty="0"/>
-              <a:t>Timing (elapsed): 0:00 welcome &amp; setup, 0:10 Part 1, 0:30 Part 2, ~1:05 short break, 1:10 Part 3a e4s-cl, 1:35 Part 3b e4s-alc, 1:55 wrap-up. Learning objectives: explain why Apptainer rather than Docker; pull and inspect E4S images; run containerized apps under Slurm; run a containerized MPI app with the host MPI via e4s-cl; customize an image with e4s-alc.</a:t>
+              <a:t>Set expectations now: "Many of you came with a specific problem. Today we stay on the shared labs so everyone finishes; for your own case, email help@rcc.uchicago.edu with [E4S workshop] in the subject. That opens a ticket and I'll follow up this week." Timing (elapsed, for you): 0:00 welcome &amp; setup, 0:10 Part 1, 0:30 Part 2, ~1:05 short break, 1:10 Part 3a e4s-cl, 1:35 Part 3b e4s-alc, 1:55 wrap-up. The cards show each part's length (talk + hands-on); the hands-on pills show the hands-on share: Part 1 10 of 20 min, Part 2 25 of 35, Part 3a 15 of 25, Part 3b 15 of 20. Learning objectives: explain why Apptainer rather than Docker; pull and inspect E4S images; run containerized apps under Slurm; run a containerized MPI app with the host MPI via e4s-cl; customize an image with e4s-alc.</a:t>
             </a:r>
             <a:endParaRPr lang="en-US" dirty="0"/>
           </a:p>
@@ -3378,7 +3380,7 @@
           <a:p>
             <a:r>
               <a:rPr lang="en-US" dirty="0"/>
-              <a:t>Credits slide. Leave up during Q&amp;A.</a:t>
+              <a:t>Credits slide. Then advance to the last slide and leave it up during Q&amp;A.</a:t>
             </a:r>
             <a:endParaRPr lang="en-US" dirty="0"/>
           </a:p>
@@ -3402,6 +3404,94 @@
             <a:fld id="{F7021451-1387-4CA6-816F-3879F97B5CBC}" type="slidenum">
               <a:rPr lang="en-US"/>
               <a:t>32</a:t>
+            </a:fld>
+            <a:endParaRPr lang="en-US"/>
+          </a:p>
+        </p:txBody>
+      </p:sp>
+    </p:spTree>
+    <p:extLst>
+      <p:ext uri="{BB962C8B-B14F-4D97-AF65-F5344CB8AC3E}">
+        <p14:creationId xmlns:p14="http://schemas.microsoft.com/office/powerpoint/2010/main" val="1024086991"/>
+      </p:ext>
+    </p:extLst>
+  </p:cSld>
+  <p:clrMapOvr>
+    <a:masterClrMapping/>
+  </p:clrMapOvr>
+</p:notes>
+</file>
+
+<file path=ppt/notesSlides/notesSlide33.xml><?xml version="1.0" encoding="utf-8"?>
+<p:notes xmlns:a="http://schemas.openxmlformats.org/drawingml/2006/main" xmlns:r="http://schemas.openxmlformats.org/officeDocument/2006/relationships" xmlns:p="http://schemas.openxmlformats.org/presentationml/2006/main">
+  <p:cSld>
+    <p:spTree>
+      <p:nvGrpSpPr>
+        <p:cNvPr id="1" name=""/>
+        <p:cNvGrpSpPr/>
+        <p:nvPr/>
+      </p:nvGrpSpPr>
+      <p:grpSpPr>
+        <a:xfrm>
+          <a:off x="0" y="0"/>
+          <a:ext cx="0" cy="0"/>
+          <a:chOff x="0" y="0"/>
+          <a:chExt cx="0" cy="0"/>
+        </a:xfrm>
+      </p:grpSpPr>
+      <p:sp>
+        <p:nvSpPr>
+          <p:cNvPr id="2" name="Slide Image Placeholder 1"/>
+          <p:cNvSpPr>
+            <a:spLocks noGrp="1" noRot="1" noChangeAspect="1"/>
+          </p:cNvSpPr>
+          <p:nvPr>
+            <p:ph type="sldImg"/>
+          </p:nvPr>
+        </p:nvSpPr>
+        <p:spPr/>
+      </p:sp>
+      <p:sp>
+        <p:nvSpPr>
+          <p:cNvPr id="3" name="Notes Placeholder 2"/>
+          <p:cNvSpPr>
+            <a:spLocks noGrp="1"/>
+          </p:cNvSpPr>
+          <p:nvPr>
+            <p:ph type="body" idx="1"/>
+          </p:nvPr>
+        </p:nvSpPr>
+        <p:spPr/>
+        <p:txBody>
+          <a:bodyPr/>
+          <a:lstStyle/>
+          <a:p>
+            <a:r>
+              <a:rPr lang="en-US" dirty="0"/>
+              <a:t>Leave this up during Q&amp;A. When someone raises their own problem: if a lab part covers it, say which; if it takes under two minutes, do it at the end; otherwise ask them to email help@ with [E4S workshop] and note their name in instructor/followup_tracker.csv. Afterwards: rt_cli.py list --queue general --subject "E4S workshop" pulls every case.</a:t>
+            </a:r>
+            <a:endParaRPr lang="en-US" dirty="0"/>
+          </a:p>
+        </p:txBody>
+      </p:sp>
+      <p:sp>
+        <p:nvSpPr>
+          <p:cNvPr id="4" name="Slide Number Placeholder 3"/>
+          <p:cNvSpPr>
+            <a:spLocks noGrp="1"/>
+          </p:cNvSpPr>
+          <p:nvPr>
+            <p:ph type="sldNum" sz="quarter" idx="10"/>
+          </p:nvPr>
+        </p:nvSpPr>
+        <p:spPr/>
+        <p:txBody>
+          <a:bodyPr/>
+          <a:lstStyle/>
+          <a:p>
+            <a:fld id="{F7021451-1387-4CA6-816F-3879F97B5CBC}" type="slidenum">
+              <a:rPr lang="en-US"/>
+              <a:t>33</a:t>
             </a:fld>
             <a:endParaRPr lang="en-US"/>
           </a:p>
@@ -11163,7 +11253,7 @@
                   <a:schemeClr val="accent5"/>
                 </a:solidFill>
               </a:rPr>
-              <a:t>0:10</a:t>
+              <a:t>20 min</a:t>
             </a:r>
             <a:endParaRPr lang="en-US" sz="2200" dirty="0"/>
           </a:p>
@@ -11373,7 +11463,7 @@
                   <a:schemeClr val="accent5"/>
                 </a:solidFill>
               </a:rPr>
-              <a:t>0:30</a:t>
+              <a:t>35 min</a:t>
             </a:r>
             <a:endParaRPr lang="en-US" sz="2200" dirty="0"/>
           </a:p>
@@ -11583,7 +11673,7 @@
                   <a:schemeClr val="accent5"/>
                 </a:solidFill>
               </a:rPr>
-              <a:t>1:10</a:t>
+              <a:t>25 min</a:t>
             </a:r>
             <a:endParaRPr lang="en-US" sz="2200" dirty="0"/>
           </a:p>
@@ -11793,7 +11883,7 @@
                   <a:schemeClr val="accent5"/>
                 </a:solidFill>
               </a:rPr>
-              <a:t>1:35</a:t>
+              <a:t>20 min</a:t>
             </a:r>
             <a:endParaRPr lang="en-US" sz="2200" dirty="0"/>
           </a:p>
@@ -11915,7 +12005,7 @@
         </p:nvSpPr>
         <p:spPr>
           <a:xfrm>
-            <a:off x="548640" y="5303520"/>
+            <a:off x="548640" y="5166360"/>
             <a:ext cx="11064240" cy="365760"/>
           </a:xfrm>
           <a:prstGeom prst="rect">
@@ -11938,6 +12028,50 @@
                 </a:solidFill>
               </a:rPr>
               <a:t>Out of scope: building images from source — see RCC's general container workshops.</a:t>
+            </a:r>
+            <a:endParaRPr lang="en-US" sz="1500" dirty="0"/>
+          </a:p>
+        </p:txBody>
+      </p:sp>
+      <p:sp>
+        <p:nvSpPr>
+          <p:cNvPr id="32" name="own-problem"/>
+          <p:cNvSpPr txBox="1"/>
+          <p:nvPr/>
+        </p:nvSpPr>
+        <p:spPr>
+          <a:xfrm>
+            <a:off x="548640" y="5577840"/>
+            <a:ext cx="11064240" cy="502920"/>
+          </a:xfrm>
+          <a:prstGeom prst="rect">
+            <a:avLst/>
+          </a:prstGeom>
+          <a:noFill/>
+          <a:ln/>
+        </p:spPr>
+        <p:txBody>
+          <a:bodyPr wrap="square" lIns="0" tIns="0" rIns="0" bIns="0" rtlCol="0" anchor="t"/>
+          <a:lstStyle/>
+          <a:p>
+            <a:pPr indent="0" marL="0">
+              <a:buNone/>
+            </a:pPr>
+            <a:r>
+              <a:rPr lang="en-US" sz="1500" b="1" dirty="0">
+                <a:solidFill>
+                  <a:schemeClr val="accent1"/>
+                </a:solidFill>
+              </a:rPr>
+              <a:t>Your own research problem? </a:t>
+            </a:r>
+            <a:r>
+              <a:rPr lang="en-US" sz="1500" dirty="0">
+                <a:solidFill>
+                  <a:schemeClr val="tx1"/>
+                </a:solidFill>
+              </a:rPr>
+              <a:t>Note it. Today we stay on the shared labs; afterwards email help@rcc.uchicago.edu with [E4S workshop] in the subject and I'll follow up.</a:t>
             </a:r>
             <a:endParaRPr lang="en-US" sz="1500" dirty="0"/>
           </a:p>
@@ -20891,6 +21025,718 @@
               <a:t>E4S is supported by DOE ASCR and the High Performance Software Foundation. Measurements: RCC Midway3, October 2026.</a:t>
             </a:r>
             <a:endParaRPr lang="en-US" sz="1600" dirty="0"/>
+          </a:p>
+        </p:txBody>
+      </p:sp>
+    </p:spTree>
+  </p:cSld>
+  <p:clrMapOvr>
+    <a:masterClrMapping/>
+  </p:clrMapOvr>
+</p:sld>
+</file>
+
+<file path=ppt/slides/slide33.xml><?xml version="1.0" encoding="utf-8"?>
+<p:sld xmlns:a="http://schemas.openxmlformats.org/drawingml/2006/main" xmlns:r="http://schemas.openxmlformats.org/officeDocument/2006/relationships" xmlns:p="http://schemas.openxmlformats.org/presentationml/2006/main">
+  <p:cSld name="Slide 33">
+    <p:spTree>
+      <p:nvGrpSpPr>
+        <p:cNvPr id="1" name=""/>
+        <p:cNvGrpSpPr/>
+        <p:nvPr/>
+      </p:nvGrpSpPr>
+      <p:grpSpPr>
+        <a:xfrm>
+          <a:off x="0" y="0"/>
+          <a:ext cx="0" cy="0"/>
+          <a:chOff x="0" y="0"/>
+          <a:chExt cx="0" cy="0"/>
+        </a:xfrm>
+      </p:grpSpPr>
+      <p:sp>
+        <p:nvSpPr>
+          <p:cNvPr id="2" name="Text 0"/>
+          <p:cNvSpPr/>
+          <p:nvPr>
+            <p:ph idx="100" type="title" hasCustomPrompt="1"/>
+          </p:nvPr>
+        </p:nvSpPr>
+        <p:spPr>
+          <a:xfrm>
+            <a:off x="548640" y="320040"/>
+            <a:ext cx="11064240" cy="777240"/>
+          </a:xfrm>
+          <a:prstGeom prst="rect">
+            <a:avLst/>
+          </a:prstGeom>
+          <a:noFill/>
+          <a:ln/>
+        </p:spPr>
+        <p:txBody>
+          <a:bodyPr wrap="square" lIns="0" tIns="0" rIns="0" bIns="0" rtlCol="0" anchor="ctr"/>
+          <a:lstStyle/>
+          <a:p>
+            <a:pPr algn="l" indent="0" marL="0">
+              <a:buNone/>
+            </a:pPr>
+            <a:r>
+              <a:rPr lang="en-US" sz="3400" b="1" dirty="0">
+                <a:solidFill>
+                  <a:schemeClr val="tx1"/>
+                </a:solidFill>
+              </a:rPr>
+              <a:t>Questions? Your own case after today</a:t>
+            </a:r>
+            <a:endParaRPr lang="en-US" sz="3400" dirty="0"/>
+          </a:p>
+        </p:txBody>
+      </p:sp>
+      <p:sp>
+        <p:nvSpPr>
+          <p:cNvPr id="3" name="followup-email"/>
+          <p:cNvSpPr/>
+          <p:nvPr/>
+        </p:nvSpPr>
+        <p:spPr>
+          <a:xfrm>
+            <a:off x="548640" y="1371600"/>
+            <a:ext cx="6675120" cy="2373782"/>
+          </a:xfrm>
+          <a:prstGeom prst="roundRect">
+            <a:avLst>
+              <a:gd name="adj" fmla="val 3082"/>
+            </a:avLst>
+          </a:prstGeom>
+          <a:solidFill>
+            <a:schemeClr val="tx1"/>
+          </a:solidFill>
+          <a:ln/>
+        </p:spPr>
+      </p:sp>
+      <p:sp>
+        <p:nvSpPr>
+          <p:cNvPr id="4" name="followup-email-text"/>
+          <p:cNvSpPr txBox="1"/>
+          <p:nvPr/>
+        </p:nvSpPr>
+        <p:spPr>
+          <a:xfrm>
+            <a:off x="731520" y="1481328"/>
+            <a:ext cx="6309360" cy="2154326"/>
+          </a:xfrm>
+          <a:prstGeom prst="rect">
+            <a:avLst/>
+          </a:prstGeom>
+          <a:noFill/>
+          <a:ln/>
+        </p:spPr>
+        <p:txBody>
+          <a:bodyPr wrap="square" lIns="0" tIns="0" rIns="0" bIns="0" rtlCol="0" anchor="t"/>
+          <a:lstStyle/>
+          <a:p>
+            <a:pPr indent="0" marL="0">
+              <a:spcAft>
+                <a:spcPts val="200"/>
+              </a:spcAft>
+              <a:buNone/>
+            </a:pPr>
+            <a:r>
+              <a:rPr lang="en-US" sz="1500" dirty="0">
+                <a:solidFill>
+                  <a:srgbClr val="B8C4CE"/>
+                </a:solidFill>
+                <a:latin typeface="Courier New" pitchFamily="34" charset="0"/>
+                <a:ea typeface="Courier New" pitchFamily="34" charset="-122"/>
+                <a:cs typeface="Courier New" pitchFamily="34" charset="-120"/>
+              </a:rPr>
+              <a:t>To:      help@rcc.uchicago.edu</a:t>
+            </a:r>
+            <a:endParaRPr lang="en-US" sz="1500" dirty="0"/>
+          </a:p>
+          <a:p>
+            <a:pPr indent="0" marL="0">
+              <a:spcAft>
+                <a:spcPts val="200"/>
+              </a:spcAft>
+              <a:buNone/>
+            </a:pPr>
+            <a:r>
+              <a:rPr lang="en-US" sz="1500" dirty="0">
+                <a:solidFill>
+                  <a:srgbClr val="B8C4CE"/>
+                </a:solidFill>
+                <a:latin typeface="Courier New" pitchFamily="34" charset="0"/>
+                <a:ea typeface="Courier New" pitchFamily="34" charset="-122"/>
+                <a:cs typeface="Courier New" pitchFamily="34" charset="-120"/>
+              </a:rPr>
+              <a:t>Subject: [E4S workshop] &lt;software&gt;: &lt;one-line problem&gt;</a:t>
+            </a:r>
+            <a:endParaRPr lang="en-US" sz="1500" dirty="0"/>
+          </a:p>
+          <a:p>
+            <a:pPr indent="0" marL="0">
+              <a:spcAft>
+                <a:spcPts val="200"/>
+              </a:spcAft>
+              <a:buNone/>
+            </a:pPr>
+            <a:r>
+              <a:rPr lang="en-US" sz="1500" dirty="0">
+                <a:solidFill>
+                  <a:srgbClr val="B8C4CE"/>
+                </a:solidFill>
+                <a:latin typeface="Courier New" pitchFamily="34" charset="0"/>
+                <a:ea typeface="Courier New" pitchFamily="34" charset="-122"/>
+                <a:cs typeface="Courier New" pitchFamily="34" charset="-120"/>
+              </a:rPr>
+              <a:t> </a:t>
+            </a:r>
+            <a:endParaRPr lang="en-US" sz="1500" dirty="0"/>
+          </a:p>
+          <a:p>
+            <a:pPr indent="0" marL="0">
+              <a:spcAft>
+                <a:spcPts val="200"/>
+              </a:spcAft>
+              <a:buNone/>
+            </a:pPr>
+            <a:r>
+              <a:rPr lang="en-US" sz="1500" dirty="0">
+                <a:solidFill>
+                  <a:srgbClr val="B8C4CE"/>
+                </a:solidFill>
+                <a:latin typeface="Courier New" pitchFamily="34" charset="0"/>
+                <a:ea typeface="Courier New" pitchFamily="34" charset="-122"/>
+                <a:cs typeface="Courier New" pitchFamily="34" charset="-120"/>
+              </a:rPr>
+              <a:t>CNetID and PI account:</a:t>
+            </a:r>
+            <a:endParaRPr lang="en-US" sz="1500" dirty="0"/>
+          </a:p>
+          <a:p>
+            <a:pPr indent="0" marL="0">
+              <a:spcAft>
+                <a:spcPts val="200"/>
+              </a:spcAft>
+              <a:buNone/>
+            </a:pPr>
+            <a:r>
+              <a:rPr lang="en-US" sz="1500" dirty="0">
+                <a:solidFill>
+                  <a:srgbClr val="B8C4CE"/>
+                </a:solidFill>
+                <a:latin typeface="Courier New" pitchFamily="34" charset="0"/>
+                <a:ea typeface="Courier New" pitchFamily="34" charset="-122"/>
+                <a:cs typeface="Courier New" pitchFamily="34" charset="-120"/>
+              </a:rPr>
+              <a:t>Software and version:</a:t>
+            </a:r>
+            <a:endParaRPr lang="en-US" sz="1500" dirty="0"/>
+          </a:p>
+          <a:p>
+            <a:pPr indent="0" marL="0">
+              <a:spcAft>
+                <a:spcPts val="200"/>
+              </a:spcAft>
+              <a:buNone/>
+            </a:pPr>
+            <a:r>
+              <a:rPr lang="en-US" sz="1500" dirty="0">
+                <a:solidFill>
+                  <a:srgbClr val="B8C4CE"/>
+                </a:solidFill>
+                <a:latin typeface="Courier New" pitchFamily="34" charset="0"/>
+                <a:ea typeface="Courier New" pitchFamily="34" charset="-122"/>
+                <a:cs typeface="Courier New" pitchFamily="34" charset="-120"/>
+              </a:rPr>
+              <a:t>What you ran (command or sbatch script):</a:t>
+            </a:r>
+            <a:endParaRPr lang="en-US" sz="1500" dirty="0"/>
+          </a:p>
+          <a:p>
+            <a:pPr indent="0" marL="0">
+              <a:spcAft>
+                <a:spcPts val="200"/>
+              </a:spcAft>
+              <a:buNone/>
+            </a:pPr>
+            <a:r>
+              <a:rPr lang="en-US" sz="1500" dirty="0">
+                <a:solidFill>
+                  <a:srgbClr val="B8C4CE"/>
+                </a:solidFill>
+                <a:latin typeface="Courier New" pitchFamily="34" charset="0"/>
+                <a:ea typeface="Courier New" pitchFamily="34" charset="-122"/>
+                <a:cs typeface="Courier New" pitchFamily="34" charset="-120"/>
+              </a:rPr>
+              <a:t>Full error text (copied, not a screenshot):</a:t>
+            </a:r>
+            <a:endParaRPr lang="en-US" sz="1500" dirty="0"/>
+          </a:p>
+          <a:p>
+            <a:pPr indent="0" marL="0">
+              <a:spcAft>
+                <a:spcPts val="200"/>
+              </a:spcAft>
+              <a:buNone/>
+            </a:pPr>
+            <a:r>
+              <a:rPr lang="en-US" sz="1500" dirty="0">
+                <a:solidFill>
+                  <a:srgbClr val="B8C4CE"/>
+                </a:solidFill>
+                <a:latin typeface="Courier New" pitchFamily="34" charset="0"/>
+                <a:ea typeface="Courier New" pitchFamily="34" charset="-122"/>
+                <a:cs typeface="Courier New" pitchFamily="34" charset="-120"/>
+              </a:rPr>
+              <a:t>Image you used, if any:</a:t>
+            </a:r>
+            <a:endParaRPr lang="en-US" sz="1500" dirty="0"/>
+          </a:p>
+        </p:txBody>
+      </p:sp>
+      <p:sp>
+        <p:nvSpPr>
+          <p:cNvPr id="5" name="followup-0-circle"/>
+          <p:cNvSpPr/>
+          <p:nvPr/>
+        </p:nvSpPr>
+        <p:spPr>
+          <a:xfrm>
+            <a:off x="7589520" y="1417320"/>
+            <a:ext cx="685800" cy="685800"/>
+          </a:xfrm>
+          <a:prstGeom prst="ellipse">
+            <a:avLst/>
+          </a:prstGeom>
+          <a:solidFill>
+            <a:srgbClr val="2F6E9E"/>
+          </a:solidFill>
+          <a:ln/>
+        </p:spPr>
+      </p:sp>
+      <p:pic>
+        <p:nvPicPr>
+          <p:cNvPr id="6" name="followup-0-icon" descr="followup-0">    </p:cNvPr>
+          <p:cNvPicPr>
+            <a:picLocks noChangeAspect="1"/>
+          </p:cNvPicPr>
+          <p:nvPr/>
+        </p:nvPicPr>
+        <p:blipFill>
+          <a:blip r:embed="rId1"/>
+          <a:stretch>
+            <a:fillRect/>
+          </a:stretch>
+        </p:blipFill>
+        <p:spPr>
+          <a:xfrm>
+            <a:off x="7754112" y="1581912"/>
+            <a:ext cx="356616" cy="356616"/>
+          </a:xfrm>
+          <a:prstGeom prst="rect">
+            <a:avLst/>
+          </a:prstGeom>
+        </p:spPr>
+      </p:pic>
+      <p:sp>
+        <p:nvSpPr>
+          <p:cNvPr id="7" name="Text 4"/>
+          <p:cNvSpPr txBox="1"/>
+          <p:nvPr/>
+        </p:nvSpPr>
+        <p:spPr>
+          <a:xfrm>
+            <a:off x="8458200" y="1371600"/>
+            <a:ext cx="3154680" cy="411480"/>
+          </a:xfrm>
+          <a:prstGeom prst="rect">
+            <a:avLst/>
+          </a:prstGeom>
+          <a:noFill/>
+          <a:ln/>
+        </p:spPr>
+        <p:txBody>
+          <a:bodyPr wrap="square" lIns="0" tIns="0" rIns="0" bIns="0" rtlCol="0" anchor="ctr"/>
+          <a:lstStyle/>
+          <a:p>
+            <a:pPr indent="0" marL="0">
+              <a:buNone/>
+            </a:pPr>
+            <a:r>
+              <a:rPr lang="en-US" sz="1800" b="1" dirty="0">
+                <a:solidFill>
+                  <a:schemeClr val="tx1"/>
+                </a:solidFill>
+              </a:rPr>
+              <a:t>Becomes an RCC ticket</a:t>
+            </a:r>
+            <a:endParaRPr lang="en-US" sz="1800" dirty="0"/>
+          </a:p>
+        </p:txBody>
+      </p:sp>
+      <p:sp>
+        <p:nvSpPr>
+          <p:cNvPr id="8" name="Text 5"/>
+          <p:cNvSpPr txBox="1"/>
+          <p:nvPr/>
+        </p:nvSpPr>
+        <p:spPr>
+          <a:xfrm>
+            <a:off x="8458200" y="1783080"/>
+            <a:ext cx="3154680" cy="685800"/>
+          </a:xfrm>
+          <a:prstGeom prst="rect">
+            <a:avLst/>
+          </a:prstGeom>
+          <a:noFill/>
+          <a:ln/>
+        </p:spPr>
+        <p:txBody>
+          <a:bodyPr wrap="square" lIns="0" tIns="0" rIns="0" bIns="0" rtlCol="0" anchor="t"/>
+          <a:lstStyle/>
+          <a:p>
+            <a:pPr indent="0" marL="0">
+              <a:buNone/>
+            </a:pPr>
+            <a:r>
+              <a:rPr lang="en-US" sz="1500" dirty="0">
+                <a:solidFill>
+                  <a:schemeClr val="tx1"/>
+                </a:solidFill>
+              </a:rPr>
+              <a:t>Nothing gets lost, and other RCC staff can pick it up.</a:t>
+            </a:r>
+            <a:endParaRPr lang="en-US" sz="1500" dirty="0"/>
+          </a:p>
+        </p:txBody>
+      </p:sp>
+      <p:sp>
+        <p:nvSpPr>
+          <p:cNvPr id="9" name="followup-1-circle"/>
+          <p:cNvSpPr/>
+          <p:nvPr/>
+        </p:nvSpPr>
+        <p:spPr>
+          <a:xfrm>
+            <a:off x="7589520" y="2606040"/>
+            <a:ext cx="685800" cy="685800"/>
+          </a:xfrm>
+          <a:prstGeom prst="ellipse">
+            <a:avLst/>
+          </a:prstGeom>
+          <a:solidFill>
+            <a:srgbClr val="4E8A3C"/>
+          </a:solidFill>
+          <a:ln/>
+        </p:spPr>
+      </p:sp>
+      <p:pic>
+        <p:nvPicPr>
+          <p:cNvPr id="10" name="followup-1-icon" descr="followup-1">    </p:cNvPr>
+          <p:cNvPicPr>
+            <a:picLocks noChangeAspect="1"/>
+          </p:cNvPicPr>
+          <p:nvPr/>
+        </p:nvPicPr>
+        <p:blipFill>
+          <a:blip r:embed="rId2"/>
+          <a:stretch>
+            <a:fillRect/>
+          </a:stretch>
+        </p:blipFill>
+        <p:spPr>
+          <a:xfrm>
+            <a:off x="7754112" y="2770632"/>
+            <a:ext cx="356616" cy="356616"/>
+          </a:xfrm>
+          <a:prstGeom prst="rect">
+            <a:avLst/>
+          </a:prstGeom>
+        </p:spPr>
+      </p:pic>
+      <p:sp>
+        <p:nvSpPr>
+          <p:cNvPr id="11" name="Text 7"/>
+          <p:cNvSpPr txBox="1"/>
+          <p:nvPr/>
+        </p:nvSpPr>
+        <p:spPr>
+          <a:xfrm>
+            <a:off x="8458200" y="2560320"/>
+            <a:ext cx="3154680" cy="411480"/>
+          </a:xfrm>
+          <a:prstGeom prst="rect">
+            <a:avLst/>
+          </a:prstGeom>
+          <a:noFill/>
+          <a:ln/>
+        </p:spPr>
+        <p:txBody>
+          <a:bodyPr wrap="square" lIns="0" tIns="0" rIns="0" bIns="0" rtlCol="0" anchor="ctr"/>
+          <a:lstStyle/>
+          <a:p>
+            <a:pPr indent="0" marL="0">
+              <a:buNone/>
+            </a:pPr>
+            <a:r>
+              <a:rPr lang="en-US" sz="1800" b="1" dirty="0">
+                <a:solidFill>
+                  <a:schemeClr val="tx1"/>
+                </a:solidFill>
+              </a:rPr>
+              <a:t>Follow-up this week</a:t>
+            </a:r>
+            <a:endParaRPr lang="en-US" sz="1800" dirty="0"/>
+          </a:p>
+        </p:txBody>
+      </p:sp>
+      <p:sp>
+        <p:nvSpPr>
+          <p:cNvPr id="12" name="Text 8"/>
+          <p:cNvSpPr txBox="1"/>
+          <p:nvPr/>
+        </p:nvSpPr>
+        <p:spPr>
+          <a:xfrm>
+            <a:off x="8458200" y="2971800"/>
+            <a:ext cx="3154680" cy="685800"/>
+          </a:xfrm>
+          <a:prstGeom prst="rect">
+            <a:avLst/>
+          </a:prstGeom>
+          <a:noFill/>
+          <a:ln/>
+        </p:spPr>
+        <p:txBody>
+          <a:bodyPr wrap="square" lIns="0" tIns="0" rIns="0" bIns="0" rtlCol="0" anchor="t"/>
+          <a:lstStyle/>
+          <a:p>
+            <a:pPr indent="0" marL="0">
+              <a:buNone/>
+            </a:pPr>
+            <a:r>
+              <a:rPr lang="en-US" sz="1500" dirty="0">
+                <a:solidFill>
+                  <a:schemeClr val="tx1"/>
+                </a:solidFill>
+              </a:rPr>
+              <a:t>Similar cases get one shared answer or a short clinic.</a:t>
+            </a:r>
+            <a:endParaRPr lang="en-US" sz="1500" dirty="0"/>
+          </a:p>
+        </p:txBody>
+      </p:sp>
+      <p:sp>
+        <p:nvSpPr>
+          <p:cNvPr id="13" name="followup-2-circle"/>
+          <p:cNvSpPr/>
+          <p:nvPr/>
+        </p:nvSpPr>
+        <p:spPr>
+          <a:xfrm>
+            <a:off x="7589520" y="3794760"/>
+            <a:ext cx="685800" cy="685800"/>
+          </a:xfrm>
+          <a:prstGeom prst="ellipse">
+            <a:avLst/>
+          </a:prstGeom>
+          <a:solidFill>
+            <a:srgbClr val="E0731F"/>
+          </a:solidFill>
+          <a:ln/>
+        </p:spPr>
+      </p:sp>
+      <p:pic>
+        <p:nvPicPr>
+          <p:cNvPr id="14" name="followup-2-icon" descr="followup-2">    </p:cNvPr>
+          <p:cNvPicPr>
+            <a:picLocks noChangeAspect="1"/>
+          </p:cNvPicPr>
+          <p:nvPr/>
+        </p:nvPicPr>
+        <p:blipFill>
+          <a:blip r:embed="rId3"/>
+          <a:stretch>
+            <a:fillRect/>
+          </a:stretch>
+        </p:blipFill>
+        <p:spPr>
+          <a:xfrm>
+            <a:off x="7754112" y="3959352"/>
+            <a:ext cx="356616" cy="356616"/>
+          </a:xfrm>
+          <a:prstGeom prst="rect">
+            <a:avLst/>
+          </a:prstGeom>
+        </p:spPr>
+      </p:pic>
+      <p:sp>
+        <p:nvSpPr>
+          <p:cNvPr id="15" name="Text 10"/>
+          <p:cNvSpPr txBox="1"/>
+          <p:nvPr/>
+        </p:nvSpPr>
+        <p:spPr>
+          <a:xfrm>
+            <a:off x="8458200" y="3749040"/>
+            <a:ext cx="3154680" cy="411480"/>
+          </a:xfrm>
+          <a:prstGeom prst="rect">
+            <a:avLst/>
+          </a:prstGeom>
+          <a:noFill/>
+          <a:ln/>
+        </p:spPr>
+        <p:txBody>
+          <a:bodyPr wrap="square" lIns="0" tIns="0" rIns="0" bIns="0" rtlCol="0" anchor="ctr"/>
+          <a:lstStyle/>
+          <a:p>
+            <a:pPr indent="0" marL="0">
+              <a:buNone/>
+            </a:pPr>
+            <a:r>
+              <a:rPr lang="en-US" sz="1800" b="1" dirty="0">
+                <a:solidFill>
+                  <a:schemeClr val="tx1"/>
+                </a:solidFill>
+              </a:rPr>
+              <a:t>Quick ones at the break</a:t>
+            </a:r>
+            <a:endParaRPr lang="en-US" sz="1800" dirty="0"/>
+          </a:p>
+        </p:txBody>
+      </p:sp>
+      <p:sp>
+        <p:nvSpPr>
+          <p:cNvPr id="16" name="Text 11"/>
+          <p:cNvSpPr txBox="1"/>
+          <p:nvPr/>
+        </p:nvSpPr>
+        <p:spPr>
+          <a:xfrm>
+            <a:off x="8458200" y="4160520"/>
+            <a:ext cx="3154680" cy="685800"/>
+          </a:xfrm>
+          <a:prstGeom prst="rect">
+            <a:avLst/>
+          </a:prstGeom>
+          <a:noFill/>
+          <a:ln/>
+        </p:spPr>
+        <p:txBody>
+          <a:bodyPr wrap="square" lIns="0" tIns="0" rIns="0" bIns="0" rtlCol="0" anchor="t"/>
+          <a:lstStyle/>
+          <a:p>
+            <a:pPr indent="0" marL="0">
+              <a:buNone/>
+            </a:pPr>
+            <a:r>
+              <a:rPr lang="en-US" sz="1500" dirty="0">
+                <a:solidFill>
+                  <a:schemeClr val="tx1"/>
+                </a:solidFill>
+              </a:rPr>
+              <a:t>If it takes under two minutes, ask me in person.</a:t>
+            </a:r>
+            <a:endParaRPr lang="en-US" sz="1500" dirty="0"/>
+          </a:p>
+        </p:txBody>
+      </p:sp>
+      <p:sp>
+        <p:nvSpPr>
+          <p:cNvPr id="17" name="followup-address"/>
+          <p:cNvSpPr txBox="1"/>
+          <p:nvPr/>
+        </p:nvSpPr>
+        <p:spPr>
+          <a:xfrm>
+            <a:off x="548640" y="5074920"/>
+            <a:ext cx="11064240" cy="640080"/>
+          </a:xfrm>
+          <a:prstGeom prst="rect">
+            <a:avLst/>
+          </a:prstGeom>
+          <a:noFill/>
+          <a:ln/>
+        </p:spPr>
+        <p:txBody>
+          <a:bodyPr wrap="square" lIns="0" tIns="0" rIns="0" bIns="0" rtlCol="0" anchor="ctr"/>
+          <a:lstStyle/>
+          <a:p>
+            <a:pPr indent="0" marL="0">
+              <a:buNone/>
+            </a:pPr>
+            <a:r>
+              <a:rPr lang="en-US" sz="2800" b="1" dirty="0">
+                <a:solidFill>
+                  <a:schemeClr val="accent1"/>
+                </a:solidFill>
+              </a:rPr>
+              <a:t>help@rcc.uchicago.edu</a:t>
+            </a:r>
+            <a:r>
+              <a:rPr lang="en-US" sz="2800" dirty="0">
+                <a:solidFill>
+                  <a:schemeClr val="tx1"/>
+                </a:solidFill>
+              </a:rPr>
+              <a:t>   ·   subject: </a:t>
+            </a:r>
+            <a:r>
+              <a:rPr lang="en-US" sz="2800" b="1" dirty="0">
+                <a:solidFill>
+                  <a:schemeClr val="accent1"/>
+                </a:solidFill>
+              </a:rPr>
+              <a:t>[E4S workshop] …</a:t>
+            </a:r>
+            <a:endParaRPr lang="en-US" sz="2800" dirty="0"/>
+          </a:p>
+        </p:txBody>
+      </p:sp>
+      <p:sp>
+        <p:nvSpPr>
+          <p:cNvPr id="25" name="Slide Number Placeholder 0"/>
+          <p:cNvSpPr>
+            <a:spLocks noGrp="1"/>
+          </p:cNvSpPr>
+          <p:nvPr>
+            <p:ph type="sldNum" sz="quarter" idx="4294967295"/>
+          </p:nvPr>
+        </p:nvSpPr>
+        <p:spPr>
+          <a:xfrm>
+            <a:off x="11155680" y="6446520"/>
+            <a:ext cx="457200" cy="274320"/>
+          </a:xfrm>
+          <a:prstGeom prst="rect">
+            <a:avLst/>
+          </a:prstGeom>
+          <a:extLst>
+            <a:ext uri="{C572A759-6A51-4108-AA02-DFA0A04FC94B}">
+              <ma14:wrappingTextBoxFlag xmlns:ma14="http://schemas.microsoft.com/office/mac/drawingml/2011/main" val="0"/>
+            </a:ext>
+          </a:extLst>
+        </p:spPr>
+        <p:txBody>
+          <a:bodyPr/>
+          <a:lstStyle>
+            <a:lvl1pPr>
+              <a:defRPr sz="1000">
+                <a:solidFill>
+                  <a:srgbClr val="8996A3"/>
+                </a:solidFill>
+              </a:defRPr>
+            </a:lvl1pPr>
+          </a:lstStyle>
+          <a:p>
+            <a:pPr algn="r"/>
+            <a:fld id="{F7021451-1387-4CA6-816F-3879F97B5CBC}" type="slidenum">
+              <a:rPr b="0" lang="en-US"/>
+              <a:t>33</a:t>
+            </a:fld>
+            <a:endParaRPr lang="en-US"/>
           </a:p>
         </p:txBody>
       </p:sp>

</xml_diff>

<commit_message>
Add the RCC logo to the slides
The reverse (white) RCC signature logo sits on the title and thank-you
slides, and a small maroon one in the footer of every content slide.
Both come from rcc-uchicago/RCC-New-Logos. LICENSE and THIRD_PARTY.md
note that the logos are University of Chicago marks, not covered by
this repository's licenses.
</commit_message>
<xml_diff>
--- a/slides/E4S_Workshop_RCC_2026-10-27.pptx
+++ b/slides/E4S_Workshop_RCC_2026-10-27.pptx
@@ -139,7 +139,7 @@
   <p:extLst>
     <p:ext uri="{521415D9-36F7-43E2-AB2F-B90AF26B5E84}">
       <p14:sectionLst xmlns:p14="http://schemas.microsoft.com/office/powerpoint/2010/main">
-        <p14:section name="Opening" id="{1e013ab6-07ef-e409-9beb-1b785ddd4d8b}">
+        <p14:section name="Opening" id="{2c63a94d-b350-7514-2cac-1598b9964323}">
           <p14:sldIdLst>
             <p14:sldId id="256"/>
             <p14:sldId id="257"/>
@@ -147,7 +147,7 @@
             <p14:sldId id="259"/>
           </p14:sldIdLst>
         </p14:section>
-        <p14:section name="Part 1: Containers on HPC" id="{ec590041-eabb-e259-6aea-5c9ae9c45f25}">
+        <p14:section name="Part 1: Containers on HPC" id="{a3a2b31d-2258-f9d6-140c-143d6d392ea8}">
           <p14:sldIdLst>
             <p14:sldId id="260"/>
             <p14:sldId id="261"/>
@@ -157,7 +157,7 @@
             <p14:sldId id="265"/>
           </p14:sldIdLst>
         </p14:section>
-        <p14:section name="Part 2: Pull, inspect, run" id="{63c40bf0-ae65-c6d2-38fb-dd6d3ac525d4}">
+        <p14:section name="Part 2: Pull, inspect, run" id="{1f6e26da-ab65-ba85-3b4a-110106692ec0}">
           <p14:sldIdLst>
             <p14:sldId id="266"/>
             <p14:sldId id="267"/>
@@ -169,7 +169,7 @@
             <p14:sldId id="273"/>
           </p14:sldIdLst>
         </p14:section>
-        <p14:section name="Part 3: e4s-cl and e4s-alc" id="{b18ef15b-43af-6bea-3426-ac6abc5d98e0}">
+        <p14:section name="Part 3: e4s-cl and e4s-alc" id="{661c2ea2-ccd6-692f-e133-20410f33e440}">
           <p14:sldIdLst>
             <p14:sldId id="274"/>
             <p14:sldId id="275"/>
@@ -184,7 +184,7 @@
             <p14:sldId id="284"/>
           </p14:sldIdLst>
         </p14:section>
-        <p14:section name="Wrap-up" id="{4c54215b-8f6b-e310-9293-e458dfbdf2a0}">
+        <p14:section name="Wrap-up" id="{dbedf2c5-72f7-5c7b-21a7-6d0e619dd32c}">
           <p14:sldIdLst>
             <p14:sldId id="285"/>
             <p14:sldId id="286"/>
@@ -4209,6 +4209,30 @@
           </a:p>
         </p:txBody>
       </p:sp>
+      <p:pic>
+        <p:nvPicPr>
+          <p:cNvPr id="5" name="Image 0" descr="The University of Chicago, Office of Research and National Laboratories, Research Computing Center">    </p:cNvPr>
+          <p:cNvPicPr>
+            <a:picLocks noChangeAspect="1"/>
+          </p:cNvPicPr>
+          <p:nvPr/>
+        </p:nvPicPr>
+        <p:blipFill>
+          <a:blip r:embed="rId1"/>
+          <a:stretch>
+            <a:fillRect/>
+          </a:stretch>
+        </p:blipFill>
+        <p:spPr>
+          <a:xfrm>
+            <a:off x="731520" y="640080"/>
+            <a:ext cx="4754880" cy="513527"/>
+          </a:xfrm>
+          <a:prstGeom prst="rect">
+            <a:avLst/>
+          </a:prstGeom>
+        </p:spPr>
+      </p:pic>
     </p:spTree>
   </p:cSld>
   <p:clrMapOvr>
@@ -4438,7 +4462,7 @@
         <p:spPr>
           <a:xfrm>
             <a:off x="548640" y="6446520"/>
-            <a:ext cx="8229600" cy="274320"/>
+            <a:ext cx="7772400" cy="274320"/>
           </a:xfrm>
           <a:prstGeom prst="rect">
             <a:avLst/>
@@ -4465,6 +4489,30 @@
           </a:p>
         </p:txBody>
       </p:sp>
+      <p:pic>
+        <p:nvPicPr>
+          <p:cNvPr id="4" name="Image 0" descr="The University of Chicago, Office of Research and National Laboratories, Research Computing Center">    </p:cNvPr>
+          <p:cNvPicPr>
+            <a:picLocks noChangeAspect="1"/>
+          </p:cNvPicPr>
+          <p:nvPr/>
+        </p:nvPicPr>
+        <p:blipFill>
+          <a:blip r:embed="rId1"/>
+          <a:stretch>
+            <a:fillRect/>
+          </a:stretch>
+        </p:blipFill>
+        <p:spPr>
+          <a:xfrm>
+            <a:off x="8732520" y="6462705"/>
+            <a:ext cx="2240280" cy="241950"/>
+          </a:xfrm>
+          <a:prstGeom prst="rect">
+            <a:avLst/>
+          </a:prstGeom>
+        </p:spPr>
+      </p:pic>
       <p:sp>
         <p:nvSpPr>
           <p:cNvPr id="25" name="Slide Number Placeholder 0"/>

</xml_diff>

<commit_message>
Correct the e4s-cl srun note: bind Intel MPI's etc directory
e4s-cl launch srun hangs in Intel MPI startup only when $I_MPI_ROOT/etc (the
tuning files) is missing from the container; mpirun runs either way, and with
etc bound srun works too. make_e4scl_profile.sh already binds it. Pitfall 8 now
also covers Midway3's Slurm setup (MpiDefault=none, pmi2 only) and the
/scratch/beagle3 mount gap that mimics the hang. Slide 23's speaker note and the
recovery table are updated to match.
</commit_message>
<xml_diff>
--- a/slides/E4S_Workshop_RCC_2026-10-27.pptx
+++ b/slides/E4S_Workshop_RCC_2026-10-27.pptx
@@ -139,7 +139,7 @@
   <p:extLst>
     <p:ext uri="{521415D9-36F7-43E2-AB2F-B90AF26B5E84}">
       <p14:sectionLst xmlns:p14="http://schemas.microsoft.com/office/powerpoint/2010/main">
-        <p14:section name="Opening" id="{2c63a94d-b350-7514-2cac-1598b9964323}">
+        <p14:section name="Opening" id="{0398a703-92ea-7302-115a-24a036fa819b}">
           <p14:sldIdLst>
             <p14:sldId id="256"/>
             <p14:sldId id="257"/>
@@ -147,7 +147,7 @@
             <p14:sldId id="259"/>
           </p14:sldIdLst>
         </p14:section>
-        <p14:section name="Part 1: Containers on HPC" id="{a3a2b31d-2258-f9d6-140c-143d6d392ea8}">
+        <p14:section name="Part 1: Containers on HPC" id="{41486c80-1262-1f73-030a-f81d71440303}">
           <p14:sldIdLst>
             <p14:sldId id="260"/>
             <p14:sldId id="261"/>
@@ -157,7 +157,7 @@
             <p14:sldId id="265"/>
           </p14:sldIdLst>
         </p14:section>
-        <p14:section name="Part 2: Pull, inspect, run" id="{1f6e26da-ab65-ba85-3b4a-110106692ec0}">
+        <p14:section name="Part 2: Pull, inspect, run" id="{a41394bb-191d-2784-20a1-6a5ca7cb620f}">
           <p14:sldIdLst>
             <p14:sldId id="266"/>
             <p14:sldId id="267"/>
@@ -169,7 +169,7 @@
             <p14:sldId id="273"/>
           </p14:sldIdLst>
         </p14:section>
-        <p14:section name="Part 3: e4s-cl and e4s-alc" id="{661c2ea2-ccd6-692f-e133-20410f33e440}">
+        <p14:section name="Part 3: e4s-cl and e4s-alc" id="{395e65fc-b548-99c9-e8d8-8180ff2e3ca7}">
           <p14:sldIdLst>
             <p14:sldId id="274"/>
             <p14:sldId id="275"/>
@@ -184,7 +184,7 @@
             <p14:sldId id="284"/>
           </p14:sldIdLst>
         </p14:section>
-        <p14:section name="Wrap-up" id="{dbedf2c5-72f7-5c7b-21a7-6d0e619dd32c}">
+        <p14:section name="Wrap-up" id="{c43ad545-cb8a-4b17-c64c-8be6dfacd8a6}">
           <p14:sldIdLst>
             <p14:sldId id="285"/>
             <p14:sldId id="286"/>
@@ -2500,7 +2500,7 @@
           <a:p>
             <a:r>
               <a:rPr lang="en-US" dirty="0"/>
-              <a:t>kernel.yama.ptrace_scope=3 on Midway3 login and compute nodes, so 'e4s-cl init' and 'e4s-cl profile detect' cannot trace. The hand-built profile is equivalent. Without e4s-cl, srun --mpi=pmi2 with the same libraries bound manually works too — the hang is specific to e4s-cl's srun path, so we use mpirun, which is also the form in Sameer's slides (e4s-cl mpirun -np 4 ./a.out).</a:t>
+              <a:t>kernel.yama.ptrace_scope=3 on Midway3 login and compute nodes, so 'e4s-cl init' and 'e4s-cl profile detect' cannot trace. The hand-built profile is equivalent, and it must include Intel MPI's etc directory (its tuning files): without it, 'e4s-cl launch srun --mpi=pmi2' hangs at Intel MPI startup, while mpirun runs either way. With it, srun works too. Midway3's Slurm has MpiDefault=none and only the pmi2 plugin, so srun needs --mpi=pmi2 and I_MPI_PMI_LIBRARY pointing at Slurm's libpmi2.so. We use mpirun, which is also the form in Sameer's slides (e4s-cl mpirun -np 4 ./a.out).</a:t>
             </a:r>
             <a:endParaRPr lang="en-US" dirty="0"/>
           </a:p>

</xml_diff>